<commit_message>
fix: polish RoboFuzz PPT layout and rendering
</commit_message>
<xml_diff>
--- a/人才项目/PPT_第2-3部分/拔尖人才项目阶段进展汇报_RoboFuzz_第2-3部分.pptx
+++ b/人才项目/PPT_第2-3部分/拔尖人才项目阶段进展汇报_RoboFuzz_第2-3部分.pptx
@@ -303,7 +303,7 @@
             <a:pPr algn="r">
               <a:buNone/>
             </a:pPr>
-            <a:fld id="{01DC1F90-D489-465B-B48E-5184BCAFBA77}" type="slidenum">
+            <a:fld id="{B78C3194-4D4E-485E-BD18-37DC530E512E}" type="slidenum">
               <a:rPr b="0" lang="en-US" sz="1400" spc="-1" strike="noStrike">
                 <a:latin typeface="Times New Roman"/>
               </a:rPr>
@@ -1212,7 +1212,7 @@
         <p:txBody>
           <a:bodyPr/>
           <a:p>
-            <a:fld id="{2F5FAFA9-E761-4DB2-BF90-CB67CBEAD5E0}" type="slidenum">
+            <a:fld id="{E6D1BC0E-AE77-4C60-92CD-FC2C1A38E037}" type="slidenum">
               <a:t>&lt;#&gt;</a:t>
             </a:fld>
           </a:p>
@@ -1406,7 +1406,7 @@
         <p:txBody>
           <a:bodyPr/>
           <a:p>
-            <a:fld id="{497B2C8C-B082-4B51-BFD1-342C6EF63A24}" type="slidenum">
+            <a:fld id="{8EE3F497-67A1-4B66-9301-F2B2F58FE328}" type="slidenum">
               <a:t>&lt;#&gt;</a:t>
             </a:fld>
           </a:p>
@@ -1674,7 +1674,7 @@
         <p:txBody>
           <a:bodyPr/>
           <a:p>
-            <a:fld id="{6ABB3703-A15A-4F8A-BD77-559E0EDE78E3}" type="slidenum">
+            <a:fld id="{FCAA2D3D-9831-4E10-9C15-23B66C873A81}" type="slidenum">
               <a:t>&lt;#&gt;</a:t>
             </a:fld>
           </a:p>
@@ -2016,7 +2016,7 @@
         <p:txBody>
           <a:bodyPr/>
           <a:p>
-            <a:fld id="{34606A11-3CAD-4451-93B8-C7EF5B5E147F}" type="slidenum">
+            <a:fld id="{E49AC4AE-EEB4-462C-8AEA-C734957B3D9F}" type="slidenum">
               <a:t>&lt;#&gt;</a:t>
             </a:fld>
           </a:p>
@@ -2099,7 +2099,7 @@
         <p:txBody>
           <a:bodyPr/>
           <a:p>
-            <a:fld id="{F96984B7-2996-453B-8D2F-F7B3BB0F93BB}" type="slidenum">
+            <a:fld id="{D2883940-23B9-4839-B270-3ED027714EDB}" type="slidenum">
               <a:t>&lt;#&gt;</a:t>
             </a:fld>
           </a:p>
@@ -2256,7 +2256,7 @@
         <p:txBody>
           <a:bodyPr/>
           <a:p>
-            <a:fld id="{4F347525-D84E-4A90-8BB1-628753C01B86}" type="slidenum">
+            <a:fld id="{04A5EE2E-1AAC-4CF5-8687-B504CE5CA77E}" type="slidenum">
               <a:t>&lt;#&gt;</a:t>
             </a:fld>
           </a:p>
@@ -2413,7 +2413,7 @@
         <p:txBody>
           <a:bodyPr/>
           <a:p>
-            <a:fld id="{8BA6E677-039F-44C2-91AB-703295E3A156}" type="slidenum">
+            <a:fld id="{F791BD93-A770-4629-B3DA-69593CC4EF59}" type="slidenum">
               <a:t>&lt;#&gt;</a:t>
             </a:fld>
           </a:p>
@@ -2607,7 +2607,7 @@
         <p:txBody>
           <a:bodyPr/>
           <a:p>
-            <a:fld id="{B9D7D684-029C-4BDE-9317-B261ABAF78AD}" type="slidenum">
+            <a:fld id="{03C39496-2FBB-4418-838A-3EAAD67F2C83}" type="slidenum">
               <a:t>&lt;#&gt;</a:t>
             </a:fld>
           </a:p>
@@ -2727,7 +2727,7 @@
         <p:txBody>
           <a:bodyPr/>
           <a:p>
-            <a:fld id="{93216EF1-4AA2-44BE-9AA4-260A7B8F0C6F}" type="slidenum">
+            <a:fld id="{4AD46025-A7DF-4B35-BBF2-FDDDF0630A08}" type="slidenum">
               <a:t>&lt;#&gt;</a:t>
             </a:fld>
           </a:p>
@@ -2847,7 +2847,7 @@
         <p:txBody>
           <a:bodyPr/>
           <a:p>
-            <a:fld id="{D0517AE3-00DE-4F4F-AFC4-1304CFDB919A}" type="slidenum">
+            <a:fld id="{CFF54958-B2BB-4B93-B60C-52E5D768CC19}" type="slidenum">
               <a:t>&lt;#&gt;</a:t>
             </a:fld>
           </a:p>
@@ -3078,7 +3078,7 @@
         <p:txBody>
           <a:bodyPr/>
           <a:p>
-            <a:fld id="{1C4AFE3C-7951-4598-8A66-5E31D241162F}" type="slidenum">
+            <a:fld id="{D212721F-6F8B-4057-9E96-2A5D173F993C}" type="slidenum">
               <a:t>&lt;#&gt;</a:t>
             </a:fld>
           </a:p>
@@ -3235,7 +3235,7 @@
         <p:txBody>
           <a:bodyPr/>
           <a:p>
-            <a:fld id="{B5235D2F-D37D-40C1-AC08-17BA3F8AC915}" type="slidenum">
+            <a:fld id="{4B34BB87-BF59-4AFD-A4C4-7F3445532285}" type="slidenum">
               <a:t>&lt;#&gt;</a:t>
             </a:fld>
           </a:p>
@@ -3466,7 +3466,7 @@
         <p:txBody>
           <a:bodyPr/>
           <a:p>
-            <a:fld id="{F09C4B99-4275-496E-9104-2F1F148BA04D}" type="slidenum">
+            <a:fld id="{ABCE2DFA-4D7D-4BA8-B147-A6101E71B98D}" type="slidenum">
               <a:t>&lt;#&gt;</a:t>
             </a:fld>
           </a:p>
@@ -3697,7 +3697,7 @@
         <p:txBody>
           <a:bodyPr/>
           <a:p>
-            <a:fld id="{226F78CF-4987-4983-ACFC-4968B481E01C}" type="slidenum">
+            <a:fld id="{336DE23D-E795-44CF-8525-A1DE90AFB346}" type="slidenum">
               <a:t>&lt;#&gt;</a:t>
             </a:fld>
           </a:p>
@@ -3891,7 +3891,7 @@
         <p:txBody>
           <a:bodyPr/>
           <a:p>
-            <a:fld id="{C52E4B13-331C-4243-8C2C-D6D0E673F86C}" type="slidenum">
+            <a:fld id="{856E7F9B-5A2D-4F0F-9A57-DABEAC49FA0D}" type="slidenum">
               <a:t>&lt;#&gt;</a:t>
             </a:fld>
           </a:p>
@@ -4159,7 +4159,7 @@
         <p:txBody>
           <a:bodyPr/>
           <a:p>
-            <a:fld id="{E2340044-EFB0-4278-B8C0-3DE656946408}" type="slidenum">
+            <a:fld id="{4BF0C157-8354-4C32-986A-C0A4D6276CE4}" type="slidenum">
               <a:t>&lt;#&gt;</a:t>
             </a:fld>
           </a:p>
@@ -4501,7 +4501,7 @@
         <p:txBody>
           <a:bodyPr/>
           <a:p>
-            <a:fld id="{1F747602-0227-4295-B7EA-8593C6D6EF05}" type="slidenum">
+            <a:fld id="{5A592775-183A-4C98-BBE4-DF3D8025F04B}" type="slidenum">
               <a:t>&lt;#&gt;</a:t>
             </a:fld>
           </a:p>
@@ -4584,7 +4584,7 @@
         <p:txBody>
           <a:bodyPr/>
           <a:p>
-            <a:fld id="{720B3A13-F541-46F1-BF2C-847AB4CC06AC}" type="slidenum">
+            <a:fld id="{C6CA9F7E-B5AA-49C4-B748-3DA2157A332C}" type="slidenum">
               <a:t>&lt;#&gt;</a:t>
             </a:fld>
           </a:p>
@@ -4741,7 +4741,7 @@
         <p:txBody>
           <a:bodyPr/>
           <a:p>
-            <a:fld id="{E33AC0C9-6F4F-4BF4-B042-175665FB0609}" type="slidenum">
+            <a:fld id="{E50366D6-5DD3-41A2-9CE4-FEFC67161652}" type="slidenum">
               <a:t>&lt;#&gt;</a:t>
             </a:fld>
           </a:p>
@@ -4898,7 +4898,7 @@
         <p:txBody>
           <a:bodyPr/>
           <a:p>
-            <a:fld id="{6DA0C8E4-B979-44DF-BB13-4113F46B0789}" type="slidenum">
+            <a:fld id="{58088CFF-0478-4F44-8595-C52C8A7908E4}" type="slidenum">
               <a:t>&lt;#&gt;</a:t>
             </a:fld>
           </a:p>
@@ -5092,7 +5092,7 @@
         <p:txBody>
           <a:bodyPr/>
           <a:p>
-            <a:fld id="{6CBA473B-CCB7-4D34-998E-7E98552DF9B2}" type="slidenum">
+            <a:fld id="{C2EBBA03-343F-4447-B98B-4A319FDA0232}" type="slidenum">
               <a:t>&lt;#&gt;</a:t>
             </a:fld>
           </a:p>
@@ -5212,7 +5212,7 @@
         <p:txBody>
           <a:bodyPr/>
           <a:p>
-            <a:fld id="{0DE9247B-A678-4ADF-9980-1DADD3B71303}" type="slidenum">
+            <a:fld id="{000C65FB-BD54-4D89-BB5D-95DB5CC61A70}" type="slidenum">
               <a:t>&lt;#&gt;</a:t>
             </a:fld>
           </a:p>
@@ -5369,7 +5369,7 @@
         <p:txBody>
           <a:bodyPr/>
           <a:p>
-            <a:fld id="{A91FCD88-9C64-4B06-A9D5-65757B614F35}" type="slidenum">
+            <a:fld id="{A2F93B73-39EE-458A-896E-0B9D31CFF3FB}" type="slidenum">
               <a:t>&lt;#&gt;</a:t>
             </a:fld>
           </a:p>
@@ -5489,7 +5489,7 @@
         <p:txBody>
           <a:bodyPr/>
           <a:p>
-            <a:fld id="{6084DBD9-1A41-4B53-A627-DFDE4BD09C28}" type="slidenum">
+            <a:fld id="{1A9F66B6-2874-4EAE-8DA1-1323C0CABD1A}" type="slidenum">
               <a:t>&lt;#&gt;</a:t>
             </a:fld>
           </a:p>
@@ -5720,7 +5720,7 @@
         <p:txBody>
           <a:bodyPr/>
           <a:p>
-            <a:fld id="{FDEED94A-64FB-4287-B5E0-90BA8A3C0F04}" type="slidenum">
+            <a:fld id="{DB547F26-28B7-4064-A8B4-212F5A8140C2}" type="slidenum">
               <a:t>&lt;#&gt;</a:t>
             </a:fld>
           </a:p>
@@ -5951,7 +5951,7 @@
         <p:txBody>
           <a:bodyPr/>
           <a:p>
-            <a:fld id="{EE662218-707E-4133-A811-06231B65B2E9}" type="slidenum">
+            <a:fld id="{B42D11FE-854E-4991-AFB3-81798D0087D2}" type="slidenum">
               <a:t>&lt;#&gt;</a:t>
             </a:fld>
           </a:p>
@@ -6182,7 +6182,7 @@
         <p:txBody>
           <a:bodyPr/>
           <a:p>
-            <a:fld id="{CD091745-2E4B-425A-81A6-7D3AF388690D}" type="slidenum">
+            <a:fld id="{64D00050-2A3F-49D0-9E61-86FD163DE522}" type="slidenum">
               <a:t>&lt;#&gt;</a:t>
             </a:fld>
           </a:p>
@@ -6376,7 +6376,7 @@
         <p:txBody>
           <a:bodyPr/>
           <a:p>
-            <a:fld id="{5DEA8265-7691-478B-8E57-E676206D9563}" type="slidenum">
+            <a:fld id="{5086E083-75D3-41CC-8DB7-8E172A93AACB}" type="slidenum">
               <a:t>&lt;#&gt;</a:t>
             </a:fld>
           </a:p>
@@ -6644,7 +6644,7 @@
         <p:txBody>
           <a:bodyPr/>
           <a:p>
-            <a:fld id="{B5B60FD6-6F61-4A45-B455-BF2013388B4E}" type="slidenum">
+            <a:fld id="{1F0BC4E7-B71F-4C62-BE88-88A9011BA6A6}" type="slidenum">
               <a:t>&lt;#&gt;</a:t>
             </a:fld>
           </a:p>
@@ -6986,7 +6986,7 @@
         <p:txBody>
           <a:bodyPr/>
           <a:p>
-            <a:fld id="{E6CC9704-8763-4951-B80F-1F8DE3DC8811}" type="slidenum">
+            <a:fld id="{664EAAC9-A2EA-43CC-8F81-89C3B6C68CED}" type="slidenum">
               <a:t>&lt;#&gt;</a:t>
             </a:fld>
           </a:p>
@@ -7180,7 +7180,7 @@
         <p:txBody>
           <a:bodyPr/>
           <a:p>
-            <a:fld id="{AEA842BA-B107-4850-B7C7-33B613B4FCBE}" type="slidenum">
+            <a:fld id="{2F43A266-4406-4865-BC72-2EBF626F7129}" type="slidenum">
               <a:t>&lt;#&gt;</a:t>
             </a:fld>
           </a:p>
@@ -7300,7 +7300,7 @@
         <p:txBody>
           <a:bodyPr/>
           <a:p>
-            <a:fld id="{74DA1285-98DF-4E80-B4F6-B854BB1AA722}" type="slidenum">
+            <a:fld id="{FE13621A-D5E3-4C7B-BF26-FAD1E9981D99}" type="slidenum">
               <a:t>&lt;#&gt;</a:t>
             </a:fld>
           </a:p>
@@ -7420,7 +7420,7 @@
         <p:txBody>
           <a:bodyPr/>
           <a:p>
-            <a:fld id="{EA0AD30D-C911-49D4-B488-668862592F63}" type="slidenum">
+            <a:fld id="{30C9A6D1-288D-4C9E-85D7-FF2B54F9CCDA}" type="slidenum">
               <a:t>&lt;#&gt;</a:t>
             </a:fld>
           </a:p>
@@ -7651,7 +7651,7 @@
         <p:txBody>
           <a:bodyPr/>
           <a:p>
-            <a:fld id="{76FBD81C-3CAC-435C-B01A-AC1DEBEDD69B}" type="slidenum">
+            <a:fld id="{957B37CD-738D-4F22-B7A1-EACF07DC071A}" type="slidenum">
               <a:t>&lt;#&gt;</a:t>
             </a:fld>
           </a:p>
@@ -7882,7 +7882,7 @@
         <p:txBody>
           <a:bodyPr/>
           <a:p>
-            <a:fld id="{E34EF54B-02CF-41EA-B240-405E870236E8}" type="slidenum">
+            <a:fld id="{3A291787-E565-4B95-B9D8-2005C5A62F62}" type="slidenum">
               <a:t>&lt;#&gt;</a:t>
             </a:fld>
           </a:p>
@@ -8113,7 +8113,7 @@
         <p:txBody>
           <a:bodyPr/>
           <a:p>
-            <a:fld id="{C2002278-1DEB-46CE-962B-EF92CE778EBD}" type="slidenum">
+            <a:fld id="{BFF65AFC-AE36-49FB-9D3B-A9EC99404C2A}" type="slidenum">
               <a:t>&lt;#&gt;</a:t>
             </a:fld>
           </a:p>
@@ -10535,7 +10535,7 @@
           </a:ln>
         </p:spPr>
         <p:txBody>
-          <a:bodyPr lIns="90000" rIns="90000" tIns="45000" bIns="45000" anchor="t">
+          <a:bodyPr lIns="28800" rIns="28800" tIns="10800" bIns="10800" anchor="t">
             <a:noAutofit/>
           </a:bodyPr>
           <a:p>
@@ -10582,7 +10582,7 @@
           </a:ln>
         </p:spPr>
         <p:txBody>
-          <a:bodyPr lIns="102600" rIns="102600" tIns="57600" bIns="57600" anchor="ctr">
+          <a:bodyPr lIns="41400" rIns="41400" tIns="23400" bIns="23400" anchor="ctr">
             <a:noAutofit/>
           </a:bodyPr>
           <a:p>
@@ -13042,7 +13042,7 @@
           </a:ln>
         </p:spPr>
         <p:txBody>
-          <a:bodyPr lIns="90000" rIns="90000" tIns="45000" bIns="45000" anchor="ctr">
+          <a:bodyPr lIns="28800" rIns="28800" tIns="10800" bIns="10800" anchor="ctr">
             <a:noAutofit/>
           </a:bodyPr>
           <a:p>
@@ -14172,7 +14172,7 @@
           </a:ln>
         </p:spPr>
         <p:txBody>
-          <a:bodyPr lIns="90000" rIns="90000" tIns="45000" bIns="45000" anchor="t">
+          <a:bodyPr lIns="28800" rIns="28800" tIns="10800" bIns="10800" anchor="t">
             <a:noAutofit/>
           </a:bodyPr>
           <a:p>
@@ -14219,7 +14219,7 @@
           </a:ln>
         </p:spPr>
         <p:txBody>
-          <a:bodyPr lIns="102600" rIns="102600" tIns="57600" bIns="57600" anchor="ctr">
+          <a:bodyPr lIns="41400" rIns="41400" tIns="23400" bIns="23400" anchor="ctr">
             <a:noAutofit/>
           </a:bodyPr>
           <a:p>
@@ -14273,12 +14273,12 @@
           </a:ln>
         </p:spPr>
         <p:txBody>
-          <a:bodyPr lIns="102600" rIns="102600" tIns="57600" bIns="57600" anchor="ctr">
+          <a:bodyPr lIns="41400" rIns="41400" tIns="23400" bIns="23400" anchor="ctr">
             <a:noAutofit/>
           </a:bodyPr>
           <a:p>
             <a:r>
-              <a:rPr b="1" lang="en-US" sz="2300" spc="-1" strike="noStrike">
+              <a:rPr b="1" lang="en-US" sz="2200" spc="-1" strike="noStrike">
                 <a:solidFill>
                   <a:srgbClr val="c00000"/>
                 </a:solidFill>
@@ -14287,7 +14287,7 @@
               <a:t>□ </a:t>
             </a:r>
             <a:r>
-              <a:rPr b="1" lang="zh-CN" sz="2300" spc="-1" strike="noStrike">
+              <a:rPr b="1" lang="zh-CN" sz="2200" spc="-1" strike="noStrike">
                 <a:solidFill>
                   <a:srgbClr val="000000"/>
                 </a:solidFill>
@@ -14295,7 +14295,7 @@
               </a:rPr>
               <a:t>正确行为难定义、稀疏异常路径难激活、非崩溃偏轨难验证。</a:t>
             </a:r>
-            <a:endParaRPr b="1" lang="en-US" sz="2300" spc="-1" strike="noStrike">
+            <a:endParaRPr b="1" lang="en-US" sz="2200" spc="-1" strike="noStrike">
               <a:solidFill>
                 <a:srgbClr val="000000"/>
               </a:solidFill>
@@ -14316,8 +14316,8 @@
         </p:blipFill>
         <p:spPr>
           <a:xfrm>
-            <a:off x="576000" y="1951200"/>
-            <a:ext cx="10980000" cy="3661200"/>
+            <a:off x="1126800" y="1854000"/>
+            <a:ext cx="9936000" cy="3312000"/>
           </a:xfrm>
           <a:prstGeom prst="rect">
             <a:avLst/>
@@ -14335,8 +14335,8 @@
         </p:nvSpPr>
         <p:spPr>
           <a:xfrm>
-            <a:off x="676800" y="5738400"/>
-            <a:ext cx="1263600" cy="954000"/>
+            <a:off x="676800" y="5238000"/>
+            <a:ext cx="1263600" cy="1098000"/>
           </a:xfrm>
           <a:prstGeom prst="rect">
             <a:avLst/>
@@ -14352,7 +14352,7 @@
           </a:ln>
         </p:spPr>
         <p:txBody>
-          <a:bodyPr lIns="102600" rIns="102600" tIns="57600" bIns="57600" anchor="ctr">
+          <a:bodyPr lIns="41400" rIns="41400" tIns="23400" bIns="23400" anchor="ctr">
             <a:noAutofit/>
           </a:bodyPr>
           <a:p>
@@ -14405,7 +14405,7 @@
         </p:nvSpPr>
         <p:spPr>
           <a:xfrm>
-            <a:off x="2008800" y="5738400"/>
+            <a:off x="2008800" y="5238000"/>
             <a:ext cx="9342000" cy="752040"/>
           </a:xfrm>
           <a:prstGeom prst="rect">
@@ -14426,12 +14426,12 @@
           </a:ln>
         </p:spPr>
         <p:txBody>
-          <a:bodyPr lIns="102600" rIns="102600" tIns="57600" bIns="57600" anchor="ctr">
+          <a:bodyPr lIns="41400" rIns="41400" tIns="23400" bIns="23400" anchor="ctr">
             <a:noAutofit/>
           </a:bodyPr>
           <a:p>
             <a:r>
-              <a:rPr b="1" lang="en-US" sz="1800" spc="-1" strike="noStrike">
+              <a:rPr b="1" lang="en-US" sz="1600" spc="-1" strike="noStrike">
                 <a:solidFill>
                   <a:srgbClr val="000000"/>
                 </a:solidFill>
@@ -14440,15 +14440,15 @@
               <a:t>□ </a:t>
             </a:r>
             <a:r>
-              <a:rPr b="1" lang="zh-CN" sz="1800" spc="-1" strike="noStrike">
+              <a:rPr b="1" lang="zh-CN" sz="1600" spc="-1" strike="noStrike">
                 <a:solidFill>
                   <a:srgbClr val="000000"/>
                 </a:solidFill>
                 <a:latin typeface="Microsoft YaHei"/>
               </a:rPr>
-              <a:t>先从系统规范中明确机器人在不同状态下应当怎样响应，再生成带有控制语义的测试输入，最后结合仿真记录和回放结果确认异常是否稳定存在。</a:t>
-            </a:r>
-            <a:endParaRPr b="1" lang="en-US" sz="1800" spc="-1" strike="noStrike">
+              <a:t>先从系统规范中明确机器人在不同状态下应当怎样响应，再生成带控制语义的输入，并用仿真记录和回放结果确认异常。</a:t>
+            </a:r>
+            <a:endParaRPr b="1" lang="en-US" sz="1600" spc="-1" strike="noStrike">
               <a:solidFill>
                 <a:srgbClr val="000000"/>
               </a:solidFill>
@@ -14465,7 +14465,7 @@
         </p:nvSpPr>
         <p:spPr>
           <a:xfrm>
-            <a:off x="2008800" y="6174000"/>
+            <a:off x="2008800" y="5803200"/>
             <a:ext cx="9342000" cy="752040"/>
           </a:xfrm>
           <a:prstGeom prst="rect">
@@ -14486,12 +14486,12 @@
           </a:ln>
         </p:spPr>
         <p:txBody>
-          <a:bodyPr lIns="102600" rIns="102600" tIns="57600" bIns="57600" anchor="ctr">
+          <a:bodyPr lIns="41400" rIns="41400" tIns="23400" bIns="23400" anchor="ctr">
             <a:noAutofit/>
           </a:bodyPr>
           <a:p>
             <a:r>
-              <a:rPr b="1" lang="en-US" sz="1800" spc="-1" strike="noStrike">
+              <a:rPr b="1" lang="en-US" sz="1600" spc="-1" strike="noStrike">
                 <a:solidFill>
                   <a:srgbClr val="000000"/>
                 </a:solidFill>
@@ -14500,15 +14500,15 @@
               <a:t>□ </a:t>
             </a:r>
             <a:r>
-              <a:rPr b="1" lang="zh-CN" sz="1800" spc="-1" strike="noStrike">
+              <a:rPr b="1" lang="zh-CN" sz="1600" spc="-1" strike="noStrike">
                 <a:solidFill>
                   <a:srgbClr val="000000"/>
                 </a:solidFill>
                 <a:latin typeface="Microsoft YaHei"/>
               </a:rPr>
-              <a:t>把前述工作接成一个能够相互反馈的测试流程：验证阶段发现的问题可以反过来补充规则并调整后续输入，使测试不只是增加轮次，而是逐步逼近真正有价值的问题。</a:t>
-            </a:r>
-            <a:endParaRPr b="1" lang="en-US" sz="1800" spc="-1" strike="noStrike">
+              <a:t>验证阶段发现的问题会反过来补充规则、调整后续输入，使测试逐步逼近真正有价值的问题，而不只是增加轮次。</a:t>
+            </a:r>
+            <a:endParaRPr b="1" lang="en-US" sz="1600" spc="-1" strike="noStrike">
               <a:solidFill>
                 <a:srgbClr val="000000"/>
               </a:solidFill>
@@ -14525,7 +14525,7 @@
         </p:nvSpPr>
         <p:spPr>
           <a:xfrm>
-            <a:off x="2008800" y="6573600"/>
+            <a:off x="2008800" y="6400800"/>
             <a:ext cx="9342000" cy="752040"/>
           </a:xfrm>
           <a:prstGeom prst="rect">
@@ -14537,7 +14537,7 @@
           </a:ln>
         </p:spPr>
         <p:txBody>
-          <a:bodyPr lIns="90000" rIns="90000" tIns="45000" bIns="45000" anchor="ctr">
+          <a:bodyPr lIns="28800" rIns="28800" tIns="10800" bIns="10800" anchor="ctr">
             <a:noAutofit/>
           </a:bodyPr>
           <a:p>
@@ -14609,7 +14609,7 @@
           </a:ln>
         </p:spPr>
         <p:txBody>
-          <a:bodyPr lIns="90000" rIns="90000" tIns="45000" bIns="45000" anchor="t">
+          <a:bodyPr lIns="28800" rIns="28800" tIns="10800" bIns="10800" anchor="t">
             <a:noAutofit/>
           </a:bodyPr>
           <a:p>
@@ -14674,7 +14674,7 @@
           </a:ln>
         </p:spPr>
         <p:txBody>
-          <a:bodyPr lIns="102600" rIns="102600" tIns="57600" bIns="57600" anchor="ctr">
+          <a:bodyPr lIns="41400" rIns="41400" tIns="23400" bIns="23400" anchor="ctr">
             <a:noAutofit/>
           </a:bodyPr>
           <a:p>
@@ -14728,12 +14728,12 @@
           </a:ln>
         </p:spPr>
         <p:txBody>
-          <a:bodyPr lIns="102600" rIns="102600" tIns="57600" bIns="57600" anchor="ctr">
+          <a:bodyPr lIns="41400" rIns="41400" tIns="23400" bIns="23400" anchor="ctr">
             <a:noAutofit/>
           </a:bodyPr>
           <a:p>
             <a:r>
-              <a:rPr b="1" lang="en-US" sz="2300" spc="-1" strike="noStrike">
+              <a:rPr b="1" lang="en-US" sz="2200" spc="-1" strike="noStrike">
                 <a:solidFill>
                   <a:srgbClr val="c00000"/>
                 </a:solidFill>
@@ -14742,7 +14742,7 @@
               <a:t>□ </a:t>
             </a:r>
             <a:r>
-              <a:rPr b="1" lang="zh-CN" sz="2300" spc="-1" strike="noStrike">
+              <a:rPr b="1" lang="zh-CN" sz="2200" spc="-1" strike="noStrike">
                 <a:solidFill>
                   <a:srgbClr val="c00000"/>
                 </a:solidFill>
@@ -14751,7 +14751,7 @@
               <a:t>建模难：</a:t>
             </a:r>
             <a:r>
-              <a:rPr b="1" lang="zh-CN" sz="2300" spc="-1" strike="noStrike">
+              <a:rPr b="1" lang="zh-CN" sz="2200" spc="-1" strike="noStrike">
                 <a:solidFill>
                   <a:srgbClr val="000000"/>
                 </a:solidFill>
@@ -14759,7 +14759,7 @@
               </a:rPr>
               <a:t>多源规范异构、跨模块约束隐含，难以形成可执行且可追溯的行为判据。</a:t>
             </a:r>
-            <a:endParaRPr b="1" lang="en-US" sz="2300" spc="-1" strike="noStrike">
+            <a:endParaRPr b="1" lang="en-US" sz="2200" spc="-1" strike="noStrike">
               <a:solidFill>
                 <a:srgbClr val="000000"/>
               </a:solidFill>
@@ -14780,8 +14780,8 @@
         </p:blipFill>
         <p:spPr>
           <a:xfrm>
-            <a:off x="576000" y="1951200"/>
-            <a:ext cx="10980000" cy="3661200"/>
+            <a:off x="1126800" y="1854000"/>
+            <a:ext cx="9936000" cy="3312000"/>
           </a:xfrm>
           <a:prstGeom prst="rect">
             <a:avLst/>
@@ -14799,8 +14799,8 @@
         </p:nvSpPr>
         <p:spPr>
           <a:xfrm>
-            <a:off x="676800" y="5738400"/>
-            <a:ext cx="1263600" cy="954000"/>
+            <a:off x="676800" y="5238000"/>
+            <a:ext cx="1263600" cy="1098000"/>
           </a:xfrm>
           <a:prstGeom prst="rect">
             <a:avLst/>
@@ -14816,7 +14816,7 @@
           </a:ln>
         </p:spPr>
         <p:txBody>
-          <a:bodyPr lIns="102600" rIns="102600" tIns="57600" bIns="57600" anchor="ctr">
+          <a:bodyPr lIns="41400" rIns="41400" tIns="23400" bIns="23400" anchor="ctr">
             <a:noAutofit/>
           </a:bodyPr>
           <a:p>
@@ -14869,7 +14869,7 @@
         </p:nvSpPr>
         <p:spPr>
           <a:xfrm>
-            <a:off x="2008800" y="5738400"/>
+            <a:off x="2008800" y="5238000"/>
             <a:ext cx="9342000" cy="752040"/>
           </a:xfrm>
           <a:prstGeom prst="rect">
@@ -14890,12 +14890,12 @@
           </a:ln>
         </p:spPr>
         <p:txBody>
-          <a:bodyPr lIns="102600" rIns="102600" tIns="57600" bIns="57600" anchor="ctr">
+          <a:bodyPr lIns="41400" rIns="41400" tIns="23400" bIns="23400" anchor="ctr">
             <a:noAutofit/>
           </a:bodyPr>
           <a:p>
             <a:r>
-              <a:rPr b="1" lang="en-US" sz="1800" spc="-1" strike="noStrike">
+              <a:rPr b="1" lang="en-US" sz="1600" spc="-1" strike="noStrike">
                 <a:solidFill>
                   <a:srgbClr val="000000"/>
                 </a:solidFill>
@@ -14904,16 +14904,16 @@
               <a:t>□ </a:t>
             </a:r>
             <a:r>
-              <a:rPr b="1" lang="zh-CN" sz="1800" spc="-1" strike="noStrike">
+              <a:rPr b="1" lang="zh-CN" sz="1600" spc="-1" strike="noStrike">
                 <a:solidFill>
                   <a:srgbClr val="000000"/>
                 </a:solidFill>
                 <a:latin typeface="Microsoft YaHei"/>
               </a:rPr>
-              <a:t>先按文件类型分别处理</a:t>
-            </a:r>
-            <a:r>
-              <a:rPr b="1" lang="en-US" sz="1800" spc="-1" strike="noStrike">
+              <a:t>先按文件类型分别处理 </a:t>
+            </a:r>
+            <a:r>
+              <a:rPr b="1" lang="en-US" sz="1600" spc="-1" strike="noStrike">
                 <a:solidFill>
                   <a:srgbClr val="000000"/>
                 </a:solidFill>
@@ -14922,7 +14922,7 @@
               <a:t>Launch</a:t>
             </a:r>
             <a:r>
-              <a:rPr b="1" lang="zh-CN" sz="1800" spc="-1" strike="noStrike">
+              <a:rPr b="1" lang="zh-CN" sz="1600" spc="-1" strike="noStrike">
                 <a:solidFill>
                   <a:srgbClr val="000000"/>
                 </a:solidFill>
@@ -14931,7 +14931,7 @@
               <a:t>、</a:t>
             </a:r>
             <a:r>
-              <a:rPr b="1" lang="en-US" sz="1800" spc="-1" strike="noStrike">
+              <a:rPr b="1" lang="en-US" sz="1600" spc="-1" strike="noStrike">
                 <a:solidFill>
                   <a:srgbClr val="000000"/>
                 </a:solidFill>
@@ -14940,15 +14940,15 @@
               <a:t>YAML</a:t>
             </a:r>
             <a:r>
-              <a:rPr b="1" lang="zh-CN" sz="1800" spc="-1" strike="noStrike">
+              <a:rPr b="1" lang="zh-CN" sz="1600" spc="-1" strike="noStrike">
                 <a:solidFill>
                   <a:srgbClr val="000000"/>
                 </a:solidFill>
                 <a:latin typeface="Microsoft YaHei"/>
               </a:rPr>
-              <a:t>、接口、源码和说明文档，把与控制行为有关的内容整理成能够追溯到原文的规范片段，再据此生成结构化约束。</a:t>
-            </a:r>
-            <a:endParaRPr b="1" lang="en-US" sz="1800" spc="-1" strike="noStrike">
+              <a:t>、接口、源码和说明文档，把控制相关内容整理为可追溯的规范片段，再生成结构化约束。</a:t>
+            </a:r>
+            <a:endParaRPr b="1" lang="en-US" sz="1600" spc="-1" strike="noStrike">
               <a:solidFill>
                 <a:srgbClr val="000000"/>
               </a:solidFill>
@@ -14965,8 +14965,8 @@
         </p:nvSpPr>
         <p:spPr>
           <a:xfrm>
-            <a:off x="2008800" y="6174000"/>
-            <a:ext cx="9342000" cy="1082880"/>
+            <a:off x="2008800" y="5803200"/>
+            <a:ext cx="9342000" cy="752040"/>
           </a:xfrm>
           <a:prstGeom prst="rect">
             <a:avLst/>
@@ -14986,12 +14986,12 @@
           </a:ln>
         </p:spPr>
         <p:txBody>
-          <a:bodyPr lIns="102600" rIns="102600" tIns="57600" bIns="57600" anchor="ctr">
+          <a:bodyPr lIns="41400" rIns="41400" tIns="23400" bIns="23400" anchor="ctr">
             <a:noAutofit/>
           </a:bodyPr>
           <a:p>
             <a:r>
-              <a:rPr b="1" lang="en-US" sz="1800" spc="-1" strike="noStrike">
+              <a:rPr b="1" lang="en-US" sz="1600" spc="-1" strike="noStrike">
                 <a:solidFill>
                   <a:srgbClr val="000000"/>
                 </a:solidFill>
@@ -15000,33 +15000,33 @@
               <a:t>□ </a:t>
             </a:r>
             <a:r>
-              <a:rPr b="1" lang="zh-CN" sz="1800" spc="-1" strike="noStrike">
+              <a:rPr b="1" lang="zh-CN" sz="1600" spc="-1" strike="noStrike">
                 <a:solidFill>
                   <a:srgbClr val="000000"/>
                 </a:solidFill>
                 <a:latin typeface="Microsoft YaHei"/>
               </a:rPr>
-              <a:t>生成</a:t>
-            </a:r>
-            <a:r>
-              <a:rPr b="1" lang="en-US" sz="1800" spc="-1" strike="noStrike">
+              <a:t>生成 </a:t>
+            </a:r>
+            <a:r>
+              <a:rPr b="1" lang="en-US" sz="1600" spc="-1" strike="noStrike">
                 <a:solidFill>
                   <a:srgbClr val="000000"/>
                 </a:solidFill>
                 <a:latin typeface="Microsoft YaHei"/>
               </a:rPr>
-              <a:t>Oracle</a:t>
-            </a:r>
-            <a:r>
-              <a:rPr b="1" lang="zh-CN" sz="1800" spc="-1" strike="noStrike">
+              <a:t>Oracle </a:t>
+            </a:r>
+            <a:r>
+              <a:rPr b="1" lang="zh-CN" sz="1600" spc="-1" strike="noStrike">
                 <a:solidFill>
                   <a:srgbClr val="000000"/>
                 </a:solidFill>
                 <a:latin typeface="Microsoft YaHei"/>
               </a:rPr>
-              <a:t>时，先找到与当前行为有关的规范，再检查字段、单位、适用状态和时间条件；对于依赖具体话题或状态机的规则，再结合目标系统补充上下文，避免把模型生成内容直接当作最终判断代码。</a:t>
-            </a:r>
-            <a:endParaRPr b="1" lang="en-US" sz="1800" spc="-1" strike="noStrike">
+              <a:t>时核对字段、单位、状态和时间条件，并结合目标话题与状态机补足上下文，避免把模型输出直接当作判断代码。</a:t>
+            </a:r>
+            <a:endParaRPr b="1" lang="en-US" sz="1600" spc="-1" strike="noStrike">
               <a:solidFill>
                 <a:srgbClr val="000000"/>
               </a:solidFill>
@@ -15043,7 +15043,7 @@
         </p:nvSpPr>
         <p:spPr>
           <a:xfrm>
-            <a:off x="2008800" y="6573600"/>
+            <a:off x="2008800" y="6400800"/>
             <a:ext cx="9342000" cy="421200"/>
           </a:xfrm>
           <a:prstGeom prst="rect">
@@ -15055,7 +15055,7 @@
           </a:ln>
         </p:spPr>
         <p:txBody>
-          <a:bodyPr lIns="90000" rIns="90000" tIns="45000" bIns="45000" anchor="ctr">
+          <a:bodyPr lIns="28800" rIns="28800" tIns="10800" bIns="10800" anchor="ctr">
             <a:noAutofit/>
           </a:bodyPr>
           <a:p>
@@ -15163,7 +15163,7 @@
           </a:ln>
         </p:spPr>
         <p:txBody>
-          <a:bodyPr lIns="90000" rIns="90000" tIns="45000" bIns="45000" anchor="t">
+          <a:bodyPr lIns="28800" rIns="28800" tIns="10800" bIns="10800" anchor="t">
             <a:noAutofit/>
           </a:bodyPr>
           <a:p>
@@ -15210,7 +15210,7 @@
           </a:ln>
         </p:spPr>
         <p:txBody>
-          <a:bodyPr lIns="102600" rIns="102600" tIns="57600" bIns="57600" anchor="ctr">
+          <a:bodyPr lIns="41400" rIns="41400" tIns="23400" bIns="23400" anchor="ctr">
             <a:noAutofit/>
           </a:bodyPr>
           <a:p>
@@ -15264,12 +15264,12 @@
           </a:ln>
         </p:spPr>
         <p:txBody>
-          <a:bodyPr lIns="102600" rIns="102600" tIns="57600" bIns="57600" anchor="ctr">
+          <a:bodyPr lIns="41400" rIns="41400" tIns="23400" bIns="23400" anchor="ctr">
             <a:noAutofit/>
           </a:bodyPr>
           <a:p>
             <a:r>
-              <a:rPr b="1" lang="en-US" sz="2300" spc="-1" strike="noStrike">
+              <a:rPr b="1" lang="en-US" sz="2200" spc="-1" strike="noStrike">
                 <a:solidFill>
                   <a:srgbClr val="c00000"/>
                 </a:solidFill>
@@ -15278,7 +15278,7 @@
               <a:t>□ </a:t>
             </a:r>
             <a:r>
-              <a:rPr b="1" lang="zh-CN" sz="2300" spc="-1" strike="noStrike">
+              <a:rPr b="1" lang="zh-CN" sz="2200" spc="-1" strike="noStrike">
                 <a:solidFill>
                   <a:srgbClr val="c00000"/>
                 </a:solidFill>
@@ -15287,7 +15287,7 @@
               <a:t>激活难：</a:t>
             </a:r>
             <a:r>
-              <a:rPr b="1" lang="zh-CN" sz="2300" spc="-1" strike="noStrike">
+              <a:rPr b="1" lang="zh-CN" sz="2200" spc="-1" strike="noStrike">
                 <a:solidFill>
                   <a:srgbClr val="000000"/>
                 </a:solidFill>
@@ -15295,7 +15295,7 @@
               </a:rPr>
               <a:t>高维状态空间稀疏，单字段随机变异难以触发时序和物理耦合型异常。</a:t>
             </a:r>
-            <a:endParaRPr b="1" lang="en-US" sz="2300" spc="-1" strike="noStrike">
+            <a:endParaRPr b="1" lang="en-US" sz="2200" spc="-1" strike="noStrike">
               <a:solidFill>
                 <a:srgbClr val="000000"/>
               </a:solidFill>
@@ -15316,8 +15316,8 @@
         </p:blipFill>
         <p:spPr>
           <a:xfrm>
-            <a:off x="576000" y="1951200"/>
-            <a:ext cx="10980000" cy="3661200"/>
+            <a:off x="1126800" y="1854000"/>
+            <a:ext cx="9936000" cy="3312000"/>
           </a:xfrm>
           <a:prstGeom prst="rect">
             <a:avLst/>
@@ -15335,8 +15335,8 @@
         </p:nvSpPr>
         <p:spPr>
           <a:xfrm>
-            <a:off x="676800" y="5738400"/>
-            <a:ext cx="1263600" cy="954000"/>
+            <a:off x="676800" y="5238000"/>
+            <a:ext cx="1263600" cy="1098000"/>
           </a:xfrm>
           <a:prstGeom prst="rect">
             <a:avLst/>
@@ -15352,7 +15352,7 @@
           </a:ln>
         </p:spPr>
         <p:txBody>
-          <a:bodyPr lIns="102600" rIns="102600" tIns="57600" bIns="57600" anchor="ctr">
+          <a:bodyPr lIns="41400" rIns="41400" tIns="23400" bIns="23400" anchor="ctr">
             <a:noAutofit/>
           </a:bodyPr>
           <a:p>
@@ -15405,8 +15405,8 @@
         </p:nvSpPr>
         <p:spPr>
           <a:xfrm>
-            <a:off x="2008800" y="5738400"/>
-            <a:ext cx="9342000" cy="1082880"/>
+            <a:off x="2008800" y="5238000"/>
+            <a:ext cx="9342000" cy="752040"/>
           </a:xfrm>
           <a:prstGeom prst="rect">
             <a:avLst/>
@@ -15426,12 +15426,12 @@
           </a:ln>
         </p:spPr>
         <p:txBody>
-          <a:bodyPr lIns="102600" rIns="102600" tIns="57600" bIns="57600" anchor="ctr">
+          <a:bodyPr lIns="41400" rIns="41400" tIns="23400" bIns="23400" anchor="ctr">
             <a:noAutofit/>
           </a:bodyPr>
           <a:p>
             <a:r>
-              <a:rPr b="1" lang="en-US" sz="1800" spc="-1" strike="noStrike">
+              <a:rPr b="1" lang="en-US" sz="1600" spc="-1" strike="noStrike">
                 <a:solidFill>
                   <a:srgbClr val="000000"/>
                 </a:solidFill>
@@ -15440,15 +15440,15 @@
               <a:t>□ </a:t>
             </a:r>
             <a:r>
-              <a:rPr b="1" lang="zh-CN" sz="1800" spc="-1" strike="noStrike">
+              <a:rPr b="1" lang="zh-CN" sz="1600" spc="-1" strike="noStrike">
                 <a:solidFill>
                   <a:srgbClr val="000000"/>
                 </a:solidFill>
                 <a:latin typeface="Microsoft YaHei"/>
               </a:rPr>
-              <a:t>测试输入不再局限于修改一条消息的数值，而是根据真实控制过程组织一段连续操作，让机器人经历保持、转向、接近边界和状态切换等变化，更容易到达随机变异很难触及的状态。</a:t>
-            </a:r>
-            <a:endParaRPr b="1" lang="en-US" sz="1800" spc="-1" strike="noStrike">
+              <a:t>测试输入不再局限于修改一条消息的数值，而是根据真实控制过程组织连续操作，让机器人经历保持、转向、边界接近和状态切换。</a:t>
+            </a:r>
+            <a:endParaRPr b="1" lang="en-US" sz="1600" spc="-1" strike="noStrike">
               <a:solidFill>
                 <a:srgbClr val="000000"/>
               </a:solidFill>
@@ -15465,8 +15465,8 @@
         </p:nvSpPr>
         <p:spPr>
           <a:xfrm>
-            <a:off x="2008800" y="6174000"/>
-            <a:ext cx="9342000" cy="1082880"/>
+            <a:off x="2008800" y="5803200"/>
+            <a:ext cx="9342000" cy="752040"/>
           </a:xfrm>
           <a:prstGeom prst="rect">
             <a:avLst/>
@@ -15486,12 +15486,12 @@
           </a:ln>
         </p:spPr>
         <p:txBody>
-          <a:bodyPr lIns="102600" rIns="102600" tIns="57600" bIns="57600" anchor="ctr">
+          <a:bodyPr lIns="41400" rIns="41400" tIns="23400" bIns="23400" anchor="ctr">
             <a:noAutofit/>
           </a:bodyPr>
           <a:p>
             <a:r>
-              <a:rPr b="1" lang="en-US" sz="1800" spc="-1" strike="noStrike">
+              <a:rPr b="1" lang="en-US" sz="1600" spc="-1" strike="noStrike">
                 <a:solidFill>
                   <a:srgbClr val="000000"/>
                 </a:solidFill>
@@ -15500,15 +15500,15 @@
               <a:t>□ </a:t>
             </a:r>
             <a:r>
-              <a:rPr b="1" lang="zh-CN" sz="1800" spc="-1" strike="noStrike">
+              <a:rPr b="1" lang="zh-CN" sz="1600" spc="-1" strike="noStrike">
                 <a:solidFill>
                   <a:srgbClr val="000000"/>
                 </a:solidFill>
                 <a:latin typeface="Microsoft YaHei"/>
               </a:rPr>
-              <a:t>每轮执行结束后，综合系统响应、任务结果和数据质量挑选更有价值的种子，同时限制相似种子反复入队或长期占用预算，使后续测试既能延续有效探索，也能及时转向新的行为区域。</a:t>
-            </a:r>
-            <a:endParaRPr b="1" lang="en-US" sz="1800" spc="-1" strike="noStrike">
+              <a:t>每轮结束后根据系统响应、任务结果和数据质量保留高价值种子，并抑制相似种子反复入队，使探索及时转向新的行为区域。</a:t>
+            </a:r>
+            <a:endParaRPr b="1" lang="en-US" sz="1600" spc="-1" strike="noStrike">
               <a:solidFill>
                 <a:srgbClr val="000000"/>
               </a:solidFill>
@@ -15525,7 +15525,7 @@
         </p:nvSpPr>
         <p:spPr>
           <a:xfrm>
-            <a:off x="2008800" y="6573600"/>
+            <a:off x="2008800" y="6400800"/>
             <a:ext cx="9342000" cy="421200"/>
           </a:xfrm>
           <a:prstGeom prst="rect">
@@ -15537,7 +15537,7 @@
           </a:ln>
         </p:spPr>
         <p:txBody>
-          <a:bodyPr lIns="90000" rIns="90000" tIns="45000" bIns="45000" anchor="ctr">
+          <a:bodyPr lIns="28800" rIns="28800" tIns="10800" bIns="10800" anchor="ctr">
             <a:noAutofit/>
           </a:bodyPr>
           <a:p>
@@ -15645,7 +15645,7 @@
           </a:ln>
         </p:spPr>
         <p:txBody>
-          <a:bodyPr lIns="90000" rIns="90000" tIns="45000" bIns="45000" anchor="t">
+          <a:bodyPr lIns="28800" rIns="28800" tIns="10800" bIns="10800" anchor="t">
             <a:noAutofit/>
           </a:bodyPr>
           <a:p>
@@ -15692,7 +15692,7 @@
           </a:ln>
         </p:spPr>
         <p:txBody>
-          <a:bodyPr lIns="102600" rIns="102600" tIns="57600" bIns="57600" anchor="ctr">
+          <a:bodyPr lIns="41400" rIns="41400" tIns="23400" bIns="23400" anchor="ctr">
             <a:noAutofit/>
           </a:bodyPr>
           <a:p>
@@ -15746,12 +15746,12 @@
           </a:ln>
         </p:spPr>
         <p:txBody>
-          <a:bodyPr lIns="102600" rIns="102600" tIns="57600" bIns="57600" anchor="ctr">
+          <a:bodyPr lIns="41400" rIns="41400" tIns="23400" bIns="23400" anchor="ctr">
             <a:noAutofit/>
           </a:bodyPr>
           <a:p>
             <a:r>
-              <a:rPr b="1" lang="en-US" sz="2300" spc="-1" strike="noStrike">
+              <a:rPr b="1" lang="en-US" sz="2200" spc="-1" strike="noStrike">
                 <a:solidFill>
                   <a:srgbClr val="c00000"/>
                 </a:solidFill>
@@ -15760,7 +15760,7 @@
               <a:t>□ </a:t>
             </a:r>
             <a:r>
-              <a:rPr b="1" lang="zh-CN" sz="2300" spc="-1" strike="noStrike">
+              <a:rPr b="1" lang="zh-CN" sz="2200" spc="-1" strike="noStrike">
                 <a:solidFill>
                   <a:srgbClr val="c00000"/>
                 </a:solidFill>
@@ -15769,7 +15769,7 @@
               <a:t>判定难：</a:t>
             </a:r>
             <a:r>
-              <a:rPr b="1" lang="zh-CN" sz="2300" spc="-1" strike="noStrike">
+              <a:rPr b="1" lang="zh-CN" sz="2200" spc="-1" strike="noStrike">
                 <a:solidFill>
                   <a:srgbClr val="000000"/>
                 </a:solidFill>
@@ -15777,7 +15777,7 @@
               </a:rPr>
               <a:t>系统无崩溃、无错误码，异步多源观测和级联报警难以复现与归因。</a:t>
             </a:r>
-            <a:endParaRPr b="1" lang="en-US" sz="2300" spc="-1" strike="noStrike">
+            <a:endParaRPr b="1" lang="en-US" sz="2200" spc="-1" strike="noStrike">
               <a:solidFill>
                 <a:srgbClr val="000000"/>
               </a:solidFill>
@@ -15798,8 +15798,8 @@
         </p:blipFill>
         <p:spPr>
           <a:xfrm>
-            <a:off x="576000" y="1951200"/>
-            <a:ext cx="10980000" cy="3661200"/>
+            <a:off x="1126800" y="1854000"/>
+            <a:ext cx="9936000" cy="3312000"/>
           </a:xfrm>
           <a:prstGeom prst="rect">
             <a:avLst/>
@@ -15817,8 +15817,8 @@
         </p:nvSpPr>
         <p:spPr>
           <a:xfrm>
-            <a:off x="676800" y="5738400"/>
-            <a:ext cx="1263600" cy="954000"/>
+            <a:off x="676800" y="5238000"/>
+            <a:ext cx="1263600" cy="1098000"/>
           </a:xfrm>
           <a:prstGeom prst="rect">
             <a:avLst/>
@@ -15834,7 +15834,7 @@
           </a:ln>
         </p:spPr>
         <p:txBody>
-          <a:bodyPr lIns="102600" rIns="102600" tIns="57600" bIns="57600" anchor="ctr">
+          <a:bodyPr lIns="41400" rIns="41400" tIns="23400" bIns="23400" anchor="ctr">
             <a:noAutofit/>
           </a:bodyPr>
           <a:p>
@@ -15887,7 +15887,7 @@
         </p:nvSpPr>
         <p:spPr>
           <a:xfrm>
-            <a:off x="2008800" y="5738400"/>
+            <a:off x="2008800" y="5238000"/>
             <a:ext cx="9342000" cy="752040"/>
           </a:xfrm>
           <a:prstGeom prst="rect">
@@ -15908,12 +15908,12 @@
           </a:ln>
         </p:spPr>
         <p:txBody>
-          <a:bodyPr lIns="102600" rIns="102600" tIns="57600" bIns="57600" anchor="ctr">
+          <a:bodyPr lIns="41400" rIns="41400" tIns="23400" bIns="23400" anchor="ctr">
             <a:noAutofit/>
           </a:bodyPr>
           <a:p>
             <a:r>
-              <a:rPr b="1" lang="en-US" sz="1800" spc="-1" strike="noStrike">
+              <a:rPr b="1" lang="en-US" sz="1600" spc="-1" strike="noStrike">
                 <a:solidFill>
                   <a:srgbClr val="000000"/>
                 </a:solidFill>
@@ -15922,15 +15922,15 @@
               <a:t>□ </a:t>
             </a:r>
             <a:r>
-              <a:rPr b="1" lang="zh-CN" sz="1800" spc="-1" strike="noStrike">
+              <a:rPr b="1" lang="zh-CN" sz="1600" spc="-1" strike="noStrike">
                 <a:solidFill>
                   <a:srgbClr val="000000"/>
                 </a:solidFill>
                 <a:latin typeface="Microsoft YaHei"/>
               </a:rPr>
-              <a:t>发现偏轨后，同时保存测试输入、运行话题、仿真真值和任务结果，再用离线计算或回放确认异常能否再次出现，从而排除目标未就绪、数据缺失等环境因素。</a:t>
-            </a:r>
-            <a:endParaRPr b="1" lang="en-US" sz="1800" spc="-1" strike="noStrike">
+              <a:t>发现偏轨后，同时保存测试输入、运行话题、仿真真值和任务结果，再用离线复算或回放确认异常能否稳定复现。</a:t>
+            </a:r>
+            <a:endParaRPr b="1" lang="en-US" sz="1600" spc="-1" strike="noStrike">
               <a:solidFill>
                 <a:srgbClr val="000000"/>
               </a:solidFill>
@@ -15947,8 +15947,8 @@
         </p:nvSpPr>
         <p:spPr>
           <a:xfrm>
-            <a:off x="2008800" y="6174000"/>
-            <a:ext cx="9342000" cy="1082880"/>
+            <a:off x="2008800" y="5803200"/>
+            <a:ext cx="9342000" cy="752040"/>
           </a:xfrm>
           <a:prstGeom prst="rect">
             <a:avLst/>
@@ -15968,12 +15968,12 @@
           </a:ln>
         </p:spPr>
         <p:txBody>
-          <a:bodyPr lIns="102600" rIns="102600" tIns="57600" bIns="57600" anchor="ctr">
+          <a:bodyPr lIns="41400" rIns="41400" tIns="23400" bIns="23400" anchor="ctr">
             <a:noAutofit/>
           </a:bodyPr>
           <a:p>
             <a:r>
-              <a:rPr b="1" lang="en-US" sz="1800" spc="-1" strike="noStrike">
+              <a:rPr b="1" lang="en-US" sz="1600" spc="-1" strike="noStrike">
                 <a:solidFill>
                   <a:srgbClr val="000000"/>
                 </a:solidFill>
@@ -15982,15 +15982,15 @@
               <a:t>□ </a:t>
             </a:r>
             <a:r>
-              <a:rPr b="1" lang="zh-CN" sz="1800" spc="-1" strike="noStrike">
+              <a:rPr b="1" lang="zh-CN" sz="1600" spc="-1" strike="noStrike">
                 <a:solidFill>
                   <a:srgbClr val="000000"/>
                 </a:solidFill>
                 <a:latin typeface="Microsoft YaHei"/>
               </a:rPr>
-              <a:t>对于多次出现或彼此关联的异常，结合触发输入、发生时刻以及它们在控制链上的传递关系判断是否来自同一个原因，最终只保留证据完整、能够稳定复现的问题用于分析和上报。</a:t>
-            </a:r>
-            <a:endParaRPr b="1" lang="en-US" sz="1800" spc="-1" strike="noStrike">
+              <a:t>结合触发输入、发生时刻和控制链关系判断多次异常是否同源，只保留证据完整、可稳定复现的问题用于分析和上报。</a:t>
+            </a:r>
+            <a:endParaRPr b="1" lang="en-US" sz="1600" spc="-1" strike="noStrike">
               <a:solidFill>
                 <a:srgbClr val="000000"/>
               </a:solidFill>
@@ -16007,7 +16007,7 @@
         </p:nvSpPr>
         <p:spPr>
           <a:xfrm>
-            <a:off x="2008800" y="6573600"/>
+            <a:off x="2008800" y="6400800"/>
             <a:ext cx="9342000" cy="421200"/>
           </a:xfrm>
           <a:prstGeom prst="rect">
@@ -16019,7 +16019,7 @@
           </a:ln>
         </p:spPr>
         <p:txBody>
-          <a:bodyPr lIns="90000" rIns="90000" tIns="45000" bIns="45000" anchor="ctr">
+          <a:bodyPr lIns="28800" rIns="28800" tIns="10800" bIns="10800" anchor="ctr">
             <a:noAutofit/>
           </a:bodyPr>
           <a:p>

</xml_diff>